<commit_message>
Add atmospheric-image variants for 3 topics (chengdu, MJ, stand-up)
Cover + section pages now use text-free codex mood images (city dawn / stage
spotlight / comedy-club) with scrim; content, numbers, structure unchanged.
Technical/data/brand topics (transformer, nvidia, nl-job, solo, kids) stay
clean by design. Regenerated renders, pptx, previews for the 6 affected decks.

Co-Authored-By: Claude Fable 5 <noreply@anthropic.com>
</commit_message>
<xml_diff>
--- a/templates/decks/en/michael-jackson-king-of-pop/template.pptx
+++ b/templates/decks/en/michael-jackson-king-of-pop/template.pptx
@@ -3145,30 +3145,60 @@
           </a:p>
         </p:txBody>
       </p:sp>
-      <p:sp>
-        <p:nvSpPr>
-          <p:cNvPr id="3" name="Isosceles Triangle 2"/>
+      <p:pic>
+        <p:nvPicPr>
+          <p:cNvPr id="3" name="Picture 2" descr="" title=""/>
+          <p:cNvPicPr>
+            <a:picLocks noChangeAspect="1"/>
+          </p:cNvPicPr>
+          <p:nvPr/>
+        </p:nvPicPr>
+        <p:blipFill>
+          <a:blip r:embed="rId2"/>
+          <a:srcRect t="7812" b="7812"/>
+          <a:stretch>
+            <a:fillRect/>
+          </a:stretch>
+        </p:blipFill>
+        <p:spPr>
+          <a:xfrm>
+            <a:off x="0" y="0"/>
+            <a:ext cx="9144000" cy="5143500"/>
+          </a:xfrm>
+          <a:prstGeom prst="rect">
+            <a:avLst/>
+          </a:prstGeom>
+        </p:spPr>
+      </p:pic>
+      <p:sp>
+        <p:nvSpPr>
+          <p:cNvPr id="4" name="Rectangle 3"/>
           <p:cNvSpPr/>
           <p:nvPr/>
         </p:nvSpPr>
         <p:spPr>
           <a:xfrm>
-            <a:off x="2377440" y="0"/>
-            <a:ext cx="4389120" cy="5074920"/>
-          </a:xfrm>
-          <a:prstGeom prst="triangle">
+            <a:off x="0" y="0"/>
+            <a:ext cx="9144000" cy="5143500"/>
+          </a:xfrm>
+          <a:prstGeom prst="rect">
             <a:avLst/>
           </a:prstGeom>
           <a:gradFill>
             <a:gsLst>
               <a:gs pos="0">
-                <a:srgbClr val="E8B23A">
-                  <a:alpha val="17000"/>
+                <a:srgbClr val="000000">
+                  <a:alpha val="40000"/>
+                </a:srgbClr>
+              </a:gs>
+              <a:gs pos="52000">
+                <a:srgbClr val="000000">
+                  <a:alpha val="50000"/>
                 </a:srgbClr>
               </a:gs>
               <a:gs pos="100000">
-                <a:srgbClr val="E8B23A">
-                  <a:alpha val="0"/>
+                <a:srgbClr val="000000">
+                  <a:alpha val="52000"/>
                 </a:srgbClr>
               </a:gs>
             </a:gsLst>
@@ -3203,239 +3233,7 @@
       </p:sp>
       <p:sp>
         <p:nvSpPr>
-          <p:cNvPr id="4" name="Oval 3"/>
-          <p:cNvSpPr/>
-          <p:nvPr/>
-        </p:nvSpPr>
-        <p:spPr>
-          <a:xfrm>
-            <a:off x="2651760" y="0"/>
-            <a:ext cx="3840480" cy="2286000"/>
-          </a:xfrm>
-          <a:prstGeom prst="ellipse">
-            <a:avLst/>
-          </a:prstGeom>
-          <a:gradFill>
-            <a:gsLst>
-              <a:gs pos="0">
-                <a:srgbClr val="E8B23A">
-                  <a:alpha val="15000"/>
-                </a:srgbClr>
-              </a:gs>
-              <a:gs pos="100000">
-                <a:srgbClr val="E8B23A">
-                  <a:alpha val="0"/>
-                </a:srgbClr>
-              </a:gs>
-            </a:gsLst>
-            <a:path path="circle">
-              <a:fillToRect l="50000" t="50000" r="50000" b="50000"/>
-            </a:path>
-          </a:gradFill>
-          <a:ln>
-            <a:noFill/>
-          </a:ln>
-          <a:effectLst/>
-        </p:spPr>
-        <p:style>
-          <a:lnRef idx="1">
-            <a:schemeClr val="accent1"/>
-          </a:lnRef>
-          <a:fillRef idx="3">
-            <a:schemeClr val="accent1"/>
-          </a:fillRef>
-          <a:effectRef idx="2">
-            <a:schemeClr val="accent1"/>
-          </a:effectRef>
-          <a:fontRef idx="minor">
-            <a:schemeClr val="lt1"/>
-          </a:fontRef>
-        </p:style>
-        <p:txBody>
-          <a:bodyPr rtlCol="0" anchor="ctr"/>
-          <a:lstStyle/>
-          <a:p>
-            <a:pPr algn="ctr"/>
-          </a:p>
-        </p:txBody>
-      </p:sp>
-      <p:sp>
-        <p:nvSpPr>
-          <p:cNvPr id="5" name="Oval 4"/>
-          <p:cNvSpPr/>
-          <p:nvPr/>
-        </p:nvSpPr>
-        <p:spPr>
-          <a:xfrm>
-            <a:off x="3520440" y="0"/>
-            <a:ext cx="2103120" cy="1737360"/>
-          </a:xfrm>
-          <a:prstGeom prst="ellipse">
-            <a:avLst/>
-          </a:prstGeom>
-          <a:gradFill>
-            <a:gsLst>
-              <a:gs pos="0">
-                <a:srgbClr val="E8B23A">
-                  <a:alpha val="44000"/>
-                </a:srgbClr>
-              </a:gs>
-              <a:gs pos="100000">
-                <a:srgbClr val="E8B23A">
-                  <a:alpha val="0"/>
-                </a:srgbClr>
-              </a:gs>
-            </a:gsLst>
-            <a:path path="circle">
-              <a:fillToRect l="50000" t="50000" r="50000" b="50000"/>
-            </a:path>
-          </a:gradFill>
-          <a:ln>
-            <a:noFill/>
-          </a:ln>
-          <a:effectLst/>
-        </p:spPr>
-        <p:style>
-          <a:lnRef idx="1">
-            <a:schemeClr val="accent1"/>
-          </a:lnRef>
-          <a:fillRef idx="3">
-            <a:schemeClr val="accent1"/>
-          </a:fillRef>
-          <a:effectRef idx="2">
-            <a:schemeClr val="accent1"/>
-          </a:effectRef>
-          <a:fontRef idx="minor">
-            <a:schemeClr val="lt1"/>
-          </a:fontRef>
-        </p:style>
-        <p:txBody>
-          <a:bodyPr rtlCol="0" anchor="ctr"/>
-          <a:lstStyle/>
-          <a:p>
-            <a:pPr algn="ctr"/>
-          </a:p>
-        </p:txBody>
-      </p:sp>
-      <p:sp>
-        <p:nvSpPr>
-          <p:cNvPr id="6" name="Oval 5"/>
-          <p:cNvSpPr/>
-          <p:nvPr/>
-        </p:nvSpPr>
-        <p:spPr>
-          <a:xfrm>
-            <a:off x="731519" y="91439"/>
-            <a:ext cx="7680960" cy="4937760"/>
-          </a:xfrm>
-          <a:prstGeom prst="ellipse">
-            <a:avLst/>
-          </a:prstGeom>
-          <a:gradFill>
-            <a:gsLst>
-              <a:gs pos="0">
-                <a:srgbClr val="E8B23A">
-                  <a:alpha val="10000"/>
-                </a:srgbClr>
-              </a:gs>
-              <a:gs pos="100000">
-                <a:srgbClr val="E8B23A">
-                  <a:alpha val="0"/>
-                </a:srgbClr>
-              </a:gs>
-            </a:gsLst>
-            <a:path path="circle">
-              <a:fillToRect l="50000" t="50000" r="50000" b="50000"/>
-            </a:path>
-          </a:gradFill>
-          <a:ln>
-            <a:noFill/>
-          </a:ln>
-          <a:effectLst/>
-        </p:spPr>
-        <p:style>
-          <a:lnRef idx="1">
-            <a:schemeClr val="accent1"/>
-          </a:lnRef>
-          <a:fillRef idx="3">
-            <a:schemeClr val="accent1"/>
-          </a:fillRef>
-          <a:effectRef idx="2">
-            <a:schemeClr val="accent1"/>
-          </a:effectRef>
-          <a:fontRef idx="minor">
-            <a:schemeClr val="lt1"/>
-          </a:fontRef>
-        </p:style>
-        <p:txBody>
-          <a:bodyPr rtlCol="0" anchor="ctr"/>
-          <a:lstStyle/>
-          <a:p>
-            <a:pPr algn="ctr"/>
-          </a:p>
-        </p:txBody>
-      </p:sp>
-      <p:sp>
-        <p:nvSpPr>
-          <p:cNvPr id="7" name="Oval 6"/>
-          <p:cNvSpPr/>
-          <p:nvPr/>
-        </p:nvSpPr>
-        <p:spPr>
-          <a:xfrm>
-            <a:off x="1645919" y="3749039"/>
-            <a:ext cx="5852160" cy="1371600"/>
-          </a:xfrm>
-          <a:prstGeom prst="ellipse">
-            <a:avLst/>
-          </a:prstGeom>
-          <a:gradFill>
-            <a:gsLst>
-              <a:gs pos="0">
-                <a:srgbClr val="E8B23A">
-                  <a:alpha val="20000"/>
-                </a:srgbClr>
-              </a:gs>
-              <a:gs pos="100000">
-                <a:srgbClr val="E8B23A">
-                  <a:alpha val="0"/>
-                </a:srgbClr>
-              </a:gs>
-            </a:gsLst>
-            <a:path path="circle">
-              <a:fillToRect l="50000" t="50000" r="50000" b="50000"/>
-            </a:path>
-          </a:gradFill>
-          <a:ln>
-            <a:noFill/>
-          </a:ln>
-          <a:effectLst/>
-        </p:spPr>
-        <p:style>
-          <a:lnRef idx="1">
-            <a:schemeClr val="accent1"/>
-          </a:lnRef>
-          <a:fillRef idx="3">
-            <a:schemeClr val="accent1"/>
-          </a:fillRef>
-          <a:effectRef idx="2">
-            <a:schemeClr val="accent1"/>
-          </a:effectRef>
-          <a:fontRef idx="minor">
-            <a:schemeClr val="lt1"/>
-          </a:fontRef>
-        </p:style>
-        <p:txBody>
-          <a:bodyPr rtlCol="0" anchor="ctr"/>
-          <a:lstStyle/>
-          <a:p>
-            <a:pPr algn="ctr"/>
-          </a:p>
-        </p:txBody>
-      </p:sp>
-      <p:sp>
-        <p:nvSpPr>
-          <p:cNvPr id="8" name="Rectangle 7"/>
+          <p:cNvPr id="5" name="Rectangle 4"/>
           <p:cNvSpPr/>
           <p:nvPr/>
         </p:nvSpPr>
@@ -3491,7 +3289,7 @@
       </p:sp>
       <p:sp>
         <p:nvSpPr>
-          <p:cNvPr id="9" name="TextBox 8"/>
+          <p:cNvPr id="6" name="TextBox 5"/>
           <p:cNvSpPr txBox="1"/>
           <p:nvPr/>
         </p:nvSpPr>
@@ -3537,7 +3335,7 @@
       </p:sp>
       <p:sp>
         <p:nvSpPr>
-          <p:cNvPr id="10" name="TextBox 9"/>
+          <p:cNvPr id="7" name="TextBox 6"/>
           <p:cNvSpPr txBox="1"/>
           <p:nvPr/>
         </p:nvSpPr>
@@ -3583,7 +3381,7 @@
       </p:sp>
       <p:sp>
         <p:nvSpPr>
-          <p:cNvPr id="11" name="TextBox 10"/>
+          <p:cNvPr id="8" name="TextBox 7"/>
           <p:cNvSpPr txBox="1"/>
           <p:nvPr/>
         </p:nvSpPr>
@@ -3629,7 +3427,7 @@
       </p:sp>
       <p:sp>
         <p:nvSpPr>
-          <p:cNvPr id="12" name="Rectangle 11"/>
+          <p:cNvPr id="9" name="Rectangle 8"/>
           <p:cNvSpPr/>
           <p:nvPr/>
         </p:nvSpPr>
@@ -3673,7 +3471,7 @@
       </p:sp>
       <p:sp>
         <p:nvSpPr>
-          <p:cNvPr id="13" name="TextBox 12"/>
+          <p:cNvPr id="10" name="TextBox 9"/>
           <p:cNvSpPr txBox="1"/>
           <p:nvPr/>
         </p:nvSpPr>
@@ -3719,7 +3517,7 @@
       </p:sp>
       <p:sp>
         <p:nvSpPr>
-          <p:cNvPr id="14" name="TextBox 13"/>
+          <p:cNvPr id="11" name="TextBox 10"/>
           <p:cNvSpPr txBox="1"/>
           <p:nvPr/>
         </p:nvSpPr>
@@ -3765,7 +3563,7 @@
       </p:sp>
       <p:sp>
         <p:nvSpPr>
-          <p:cNvPr id="15" name="TextBox 14"/>
+          <p:cNvPr id="12" name="TextBox 11"/>
           <p:cNvSpPr txBox="1"/>
           <p:nvPr/>
         </p:nvSpPr>
@@ -8521,30 +8319,60 @@
           </a:p>
         </p:txBody>
       </p:sp>
-      <p:sp>
-        <p:nvSpPr>
-          <p:cNvPr id="3" name="Isosceles Triangle 2"/>
+      <p:pic>
+        <p:nvPicPr>
+          <p:cNvPr id="3" name="Picture 2" descr="" title=""/>
+          <p:cNvPicPr>
+            <a:picLocks noChangeAspect="1"/>
+          </p:cNvPicPr>
+          <p:nvPr/>
+        </p:nvPicPr>
+        <p:blipFill>
+          <a:blip r:embed="rId2"/>
+          <a:srcRect t="21875" b="21875"/>
+          <a:stretch>
+            <a:fillRect/>
+          </a:stretch>
+        </p:blipFill>
+        <p:spPr>
+          <a:xfrm>
+            <a:off x="0" y="0"/>
+            <a:ext cx="9144000" cy="5143500"/>
+          </a:xfrm>
+          <a:prstGeom prst="rect">
+            <a:avLst/>
+          </a:prstGeom>
+        </p:spPr>
+      </p:pic>
+      <p:sp>
+        <p:nvSpPr>
+          <p:cNvPr id="4" name="Rectangle 3"/>
           <p:cNvSpPr/>
           <p:nvPr/>
         </p:nvSpPr>
         <p:spPr>
           <a:xfrm>
-            <a:off x="2377440" y="0"/>
-            <a:ext cx="4389120" cy="5074920"/>
-          </a:xfrm>
-          <a:prstGeom prst="triangle">
+            <a:off x="0" y="0"/>
+            <a:ext cx="9144000" cy="5143500"/>
+          </a:xfrm>
+          <a:prstGeom prst="rect">
             <a:avLst/>
           </a:prstGeom>
           <a:gradFill>
             <a:gsLst>
               <a:gs pos="0">
-                <a:srgbClr val="E8B23A">
-                  <a:alpha val="17000"/>
+                <a:srgbClr val="000000">
+                  <a:alpha val="50000"/>
+                </a:srgbClr>
+              </a:gs>
+              <a:gs pos="50000">
+                <a:srgbClr val="000000">
+                  <a:alpha val="62000"/>
                 </a:srgbClr>
               </a:gs>
               <a:gs pos="100000">
-                <a:srgbClr val="E8B23A">
-                  <a:alpha val="0"/>
+                <a:srgbClr val="000000">
+                  <a:alpha val="66000"/>
                 </a:srgbClr>
               </a:gs>
             </a:gsLst>
@@ -8579,239 +8407,7 @@
       </p:sp>
       <p:sp>
         <p:nvSpPr>
-          <p:cNvPr id="4" name="Oval 3"/>
-          <p:cNvSpPr/>
-          <p:nvPr/>
-        </p:nvSpPr>
-        <p:spPr>
-          <a:xfrm>
-            <a:off x="2651760" y="0"/>
-            <a:ext cx="3840480" cy="2286000"/>
-          </a:xfrm>
-          <a:prstGeom prst="ellipse">
-            <a:avLst/>
-          </a:prstGeom>
-          <a:gradFill>
-            <a:gsLst>
-              <a:gs pos="0">
-                <a:srgbClr val="E8B23A">
-                  <a:alpha val="15000"/>
-                </a:srgbClr>
-              </a:gs>
-              <a:gs pos="100000">
-                <a:srgbClr val="E8B23A">
-                  <a:alpha val="0"/>
-                </a:srgbClr>
-              </a:gs>
-            </a:gsLst>
-            <a:path path="circle">
-              <a:fillToRect l="50000" t="50000" r="50000" b="50000"/>
-            </a:path>
-          </a:gradFill>
-          <a:ln>
-            <a:noFill/>
-          </a:ln>
-          <a:effectLst/>
-        </p:spPr>
-        <p:style>
-          <a:lnRef idx="1">
-            <a:schemeClr val="accent1"/>
-          </a:lnRef>
-          <a:fillRef idx="3">
-            <a:schemeClr val="accent1"/>
-          </a:fillRef>
-          <a:effectRef idx="2">
-            <a:schemeClr val="accent1"/>
-          </a:effectRef>
-          <a:fontRef idx="minor">
-            <a:schemeClr val="lt1"/>
-          </a:fontRef>
-        </p:style>
-        <p:txBody>
-          <a:bodyPr rtlCol="0" anchor="ctr"/>
-          <a:lstStyle/>
-          <a:p>
-            <a:pPr algn="ctr"/>
-          </a:p>
-        </p:txBody>
-      </p:sp>
-      <p:sp>
-        <p:nvSpPr>
-          <p:cNvPr id="5" name="Oval 4"/>
-          <p:cNvSpPr/>
-          <p:nvPr/>
-        </p:nvSpPr>
-        <p:spPr>
-          <a:xfrm>
-            <a:off x="3520440" y="0"/>
-            <a:ext cx="2103120" cy="1737360"/>
-          </a:xfrm>
-          <a:prstGeom prst="ellipse">
-            <a:avLst/>
-          </a:prstGeom>
-          <a:gradFill>
-            <a:gsLst>
-              <a:gs pos="0">
-                <a:srgbClr val="E8B23A">
-                  <a:alpha val="44000"/>
-                </a:srgbClr>
-              </a:gs>
-              <a:gs pos="100000">
-                <a:srgbClr val="E8B23A">
-                  <a:alpha val="0"/>
-                </a:srgbClr>
-              </a:gs>
-            </a:gsLst>
-            <a:path path="circle">
-              <a:fillToRect l="50000" t="50000" r="50000" b="50000"/>
-            </a:path>
-          </a:gradFill>
-          <a:ln>
-            <a:noFill/>
-          </a:ln>
-          <a:effectLst/>
-        </p:spPr>
-        <p:style>
-          <a:lnRef idx="1">
-            <a:schemeClr val="accent1"/>
-          </a:lnRef>
-          <a:fillRef idx="3">
-            <a:schemeClr val="accent1"/>
-          </a:fillRef>
-          <a:effectRef idx="2">
-            <a:schemeClr val="accent1"/>
-          </a:effectRef>
-          <a:fontRef idx="minor">
-            <a:schemeClr val="lt1"/>
-          </a:fontRef>
-        </p:style>
-        <p:txBody>
-          <a:bodyPr rtlCol="0" anchor="ctr"/>
-          <a:lstStyle/>
-          <a:p>
-            <a:pPr algn="ctr"/>
-          </a:p>
-        </p:txBody>
-      </p:sp>
-      <p:sp>
-        <p:nvSpPr>
-          <p:cNvPr id="6" name="Oval 5"/>
-          <p:cNvSpPr/>
-          <p:nvPr/>
-        </p:nvSpPr>
-        <p:spPr>
-          <a:xfrm>
-            <a:off x="731519" y="91439"/>
-            <a:ext cx="7680960" cy="4937760"/>
-          </a:xfrm>
-          <a:prstGeom prst="ellipse">
-            <a:avLst/>
-          </a:prstGeom>
-          <a:gradFill>
-            <a:gsLst>
-              <a:gs pos="0">
-                <a:srgbClr val="E8B23A">
-                  <a:alpha val="10000"/>
-                </a:srgbClr>
-              </a:gs>
-              <a:gs pos="100000">
-                <a:srgbClr val="E8B23A">
-                  <a:alpha val="0"/>
-                </a:srgbClr>
-              </a:gs>
-            </a:gsLst>
-            <a:path path="circle">
-              <a:fillToRect l="50000" t="50000" r="50000" b="50000"/>
-            </a:path>
-          </a:gradFill>
-          <a:ln>
-            <a:noFill/>
-          </a:ln>
-          <a:effectLst/>
-        </p:spPr>
-        <p:style>
-          <a:lnRef idx="1">
-            <a:schemeClr val="accent1"/>
-          </a:lnRef>
-          <a:fillRef idx="3">
-            <a:schemeClr val="accent1"/>
-          </a:fillRef>
-          <a:effectRef idx="2">
-            <a:schemeClr val="accent1"/>
-          </a:effectRef>
-          <a:fontRef idx="minor">
-            <a:schemeClr val="lt1"/>
-          </a:fontRef>
-        </p:style>
-        <p:txBody>
-          <a:bodyPr rtlCol="0" anchor="ctr"/>
-          <a:lstStyle/>
-          <a:p>
-            <a:pPr algn="ctr"/>
-          </a:p>
-        </p:txBody>
-      </p:sp>
-      <p:sp>
-        <p:nvSpPr>
-          <p:cNvPr id="7" name="Oval 6"/>
-          <p:cNvSpPr/>
-          <p:nvPr/>
-        </p:nvSpPr>
-        <p:spPr>
-          <a:xfrm>
-            <a:off x="1645919" y="3749039"/>
-            <a:ext cx="5852160" cy="1371600"/>
-          </a:xfrm>
-          <a:prstGeom prst="ellipse">
-            <a:avLst/>
-          </a:prstGeom>
-          <a:gradFill>
-            <a:gsLst>
-              <a:gs pos="0">
-                <a:srgbClr val="E8B23A">
-                  <a:alpha val="20000"/>
-                </a:srgbClr>
-              </a:gs>
-              <a:gs pos="100000">
-                <a:srgbClr val="E8B23A">
-                  <a:alpha val="0"/>
-                </a:srgbClr>
-              </a:gs>
-            </a:gsLst>
-            <a:path path="circle">
-              <a:fillToRect l="50000" t="50000" r="50000" b="50000"/>
-            </a:path>
-          </a:gradFill>
-          <a:ln>
-            <a:noFill/>
-          </a:ln>
-          <a:effectLst/>
-        </p:spPr>
-        <p:style>
-          <a:lnRef idx="1">
-            <a:schemeClr val="accent1"/>
-          </a:lnRef>
-          <a:fillRef idx="3">
-            <a:schemeClr val="accent1"/>
-          </a:fillRef>
-          <a:effectRef idx="2">
-            <a:schemeClr val="accent1"/>
-          </a:effectRef>
-          <a:fontRef idx="minor">
-            <a:schemeClr val="lt1"/>
-          </a:fontRef>
-        </p:style>
-        <p:txBody>
-          <a:bodyPr rtlCol="0" anchor="ctr"/>
-          <a:lstStyle/>
-          <a:p>
-            <a:pPr algn="ctr"/>
-          </a:p>
-        </p:txBody>
-      </p:sp>
-      <p:sp>
-        <p:nvSpPr>
-          <p:cNvPr id="8" name="Rectangle 7"/>
+          <p:cNvPr id="5" name="Rectangle 4"/>
           <p:cNvSpPr/>
           <p:nvPr/>
         </p:nvSpPr>
@@ -8867,7 +8463,7 @@
       </p:sp>
       <p:sp>
         <p:nvSpPr>
-          <p:cNvPr id="9" name="TextBox 8"/>
+          <p:cNvPr id="6" name="TextBox 5"/>
           <p:cNvSpPr txBox="1"/>
           <p:nvPr/>
         </p:nvSpPr>
@@ -8913,7 +8509,7 @@
       </p:sp>
       <p:sp>
         <p:nvSpPr>
-          <p:cNvPr id="10" name="TextBox 9"/>
+          <p:cNvPr id="7" name="TextBox 6"/>
           <p:cNvSpPr txBox="1"/>
           <p:nvPr/>
         </p:nvSpPr>
@@ -8959,7 +8555,7 @@
       </p:sp>
       <p:sp>
         <p:nvSpPr>
-          <p:cNvPr id="11" name="Rectangle 10"/>
+          <p:cNvPr id="8" name="Rectangle 7"/>
           <p:cNvSpPr/>
           <p:nvPr/>
         </p:nvSpPr>
@@ -9003,7 +8599,7 @@
       </p:sp>
       <p:sp>
         <p:nvSpPr>
-          <p:cNvPr id="12" name="TextBox 11"/>
+          <p:cNvPr id="9" name="TextBox 8"/>
           <p:cNvSpPr txBox="1"/>
           <p:nvPr/>
         </p:nvSpPr>
@@ -9049,7 +8645,7 @@
       </p:sp>
       <p:sp>
         <p:nvSpPr>
-          <p:cNvPr id="13" name="TextBox 12"/>
+          <p:cNvPr id="10" name="TextBox 9"/>
           <p:cNvSpPr txBox="1"/>
           <p:nvPr/>
         </p:nvSpPr>
@@ -9095,7 +8691,7 @@
       </p:sp>
       <p:sp>
         <p:nvSpPr>
-          <p:cNvPr id="14" name="TextBox 13"/>
+          <p:cNvPr id="11" name="TextBox 10"/>
           <p:cNvSpPr txBox="1"/>
           <p:nvPr/>
         </p:nvSpPr>
@@ -9141,7 +8737,7 @@
       </p:sp>
       <p:sp>
         <p:nvSpPr>
-          <p:cNvPr id="15" name="TextBox 14"/>
+          <p:cNvPr id="12" name="TextBox 11"/>
           <p:cNvSpPr txBox="1"/>
           <p:nvPr/>
         </p:nvSpPr>
@@ -14131,34 +13727,64 @@
           </a:p>
         </p:txBody>
       </p:sp>
-      <p:sp>
-        <p:nvSpPr>
-          <p:cNvPr id="3" name="Isosceles Triangle 2"/>
+      <p:pic>
+        <p:nvPicPr>
+          <p:cNvPr id="3" name="Picture 2" descr="" title=""/>
+          <p:cNvPicPr>
+            <a:picLocks noChangeAspect="1"/>
+          </p:cNvPicPr>
+          <p:nvPr/>
+        </p:nvPicPr>
+        <p:blipFill>
+          <a:blip r:embed="rId2"/>
+          <a:srcRect l="13556" r="13556"/>
+          <a:stretch>
+            <a:fillRect/>
+          </a:stretch>
+        </p:blipFill>
+        <p:spPr>
+          <a:xfrm>
+            <a:off x="5394960" y="0"/>
+            <a:ext cx="3749039" cy="5143500"/>
+          </a:xfrm>
+          <a:prstGeom prst="rect">
+            <a:avLst/>
+          </a:prstGeom>
+        </p:spPr>
+      </p:pic>
+      <p:sp>
+        <p:nvSpPr>
+          <p:cNvPr id="4" name="Rectangle 3"/>
           <p:cNvSpPr/>
           <p:nvPr/>
         </p:nvSpPr>
         <p:spPr>
           <a:xfrm>
-            <a:off x="2377440" y="0"/>
-            <a:ext cx="4389120" cy="5074920"/>
-          </a:xfrm>
-          <a:prstGeom prst="triangle">
+            <a:off x="4754880" y="0"/>
+            <a:ext cx="4389120" cy="5143500"/>
+          </a:xfrm>
+          <a:prstGeom prst="rect">
             <a:avLst/>
           </a:prstGeom>
           <a:gradFill>
             <a:gsLst>
               <a:gs pos="0">
-                <a:srgbClr val="E8B23A">
-                  <a:alpha val="17000"/>
+                <a:srgbClr val="0E0D13">
+                  <a:alpha val="100000"/>
                 </a:srgbClr>
               </a:gs>
-              <a:gs pos="100000">
-                <a:srgbClr val="E8B23A">
+              <a:gs pos="34000">
+                <a:srgbClr val="0E0D13">
+                  <a:alpha val="16000"/>
+                </a:srgbClr>
+              </a:gs>
+              <a:gs pos="62000">
+                <a:srgbClr val="0E0D13">
                   <a:alpha val="0"/>
                 </a:srgbClr>
               </a:gs>
             </a:gsLst>
-            <a:lin ang="5400000" scaled="1"/>
+            <a:lin ang="0" scaled="1"/>
           </a:gradFill>
           <a:ln>
             <a:noFill/>
@@ -14189,246 +13815,14 @@
       </p:sp>
       <p:sp>
         <p:nvSpPr>
-          <p:cNvPr id="4" name="Oval 3"/>
-          <p:cNvSpPr/>
-          <p:nvPr/>
-        </p:nvSpPr>
-        <p:spPr>
-          <a:xfrm>
-            <a:off x="2651760" y="0"/>
-            <a:ext cx="3840480" cy="2286000"/>
-          </a:xfrm>
-          <a:prstGeom prst="ellipse">
-            <a:avLst/>
-          </a:prstGeom>
-          <a:gradFill>
-            <a:gsLst>
-              <a:gs pos="0">
-                <a:srgbClr val="E8B23A">
-                  <a:alpha val="15000"/>
-                </a:srgbClr>
-              </a:gs>
-              <a:gs pos="100000">
-                <a:srgbClr val="E8B23A">
-                  <a:alpha val="0"/>
-                </a:srgbClr>
-              </a:gs>
-            </a:gsLst>
-            <a:path path="circle">
-              <a:fillToRect l="50000" t="50000" r="50000" b="50000"/>
-            </a:path>
-          </a:gradFill>
-          <a:ln>
-            <a:noFill/>
-          </a:ln>
-          <a:effectLst/>
-        </p:spPr>
-        <p:style>
-          <a:lnRef idx="1">
-            <a:schemeClr val="accent1"/>
-          </a:lnRef>
-          <a:fillRef idx="3">
-            <a:schemeClr val="accent1"/>
-          </a:fillRef>
-          <a:effectRef idx="2">
-            <a:schemeClr val="accent1"/>
-          </a:effectRef>
-          <a:fontRef idx="minor">
-            <a:schemeClr val="lt1"/>
-          </a:fontRef>
-        </p:style>
-        <p:txBody>
-          <a:bodyPr rtlCol="0" anchor="ctr"/>
-          <a:lstStyle/>
-          <a:p>
-            <a:pPr algn="ctr"/>
-          </a:p>
-        </p:txBody>
-      </p:sp>
-      <p:sp>
-        <p:nvSpPr>
-          <p:cNvPr id="5" name="Oval 4"/>
-          <p:cNvSpPr/>
-          <p:nvPr/>
-        </p:nvSpPr>
-        <p:spPr>
-          <a:xfrm>
-            <a:off x="3520440" y="0"/>
-            <a:ext cx="2103120" cy="1737360"/>
-          </a:xfrm>
-          <a:prstGeom prst="ellipse">
-            <a:avLst/>
-          </a:prstGeom>
-          <a:gradFill>
-            <a:gsLst>
-              <a:gs pos="0">
-                <a:srgbClr val="E8B23A">
-                  <a:alpha val="44000"/>
-                </a:srgbClr>
-              </a:gs>
-              <a:gs pos="100000">
-                <a:srgbClr val="E8B23A">
-                  <a:alpha val="0"/>
-                </a:srgbClr>
-              </a:gs>
-            </a:gsLst>
-            <a:path path="circle">
-              <a:fillToRect l="50000" t="50000" r="50000" b="50000"/>
-            </a:path>
-          </a:gradFill>
-          <a:ln>
-            <a:noFill/>
-          </a:ln>
-          <a:effectLst/>
-        </p:spPr>
-        <p:style>
-          <a:lnRef idx="1">
-            <a:schemeClr val="accent1"/>
-          </a:lnRef>
-          <a:fillRef idx="3">
-            <a:schemeClr val="accent1"/>
-          </a:fillRef>
-          <a:effectRef idx="2">
-            <a:schemeClr val="accent1"/>
-          </a:effectRef>
-          <a:fontRef idx="minor">
-            <a:schemeClr val="lt1"/>
-          </a:fontRef>
-        </p:style>
-        <p:txBody>
-          <a:bodyPr rtlCol="0" anchor="ctr"/>
-          <a:lstStyle/>
-          <a:p>
-            <a:pPr algn="ctr"/>
-          </a:p>
-        </p:txBody>
-      </p:sp>
-      <p:sp>
-        <p:nvSpPr>
-          <p:cNvPr id="6" name="Oval 5"/>
-          <p:cNvSpPr/>
-          <p:nvPr/>
-        </p:nvSpPr>
-        <p:spPr>
-          <a:xfrm>
-            <a:off x="731519" y="91439"/>
-            <a:ext cx="7680960" cy="4937760"/>
-          </a:xfrm>
-          <a:prstGeom prst="ellipse">
-            <a:avLst/>
-          </a:prstGeom>
-          <a:gradFill>
-            <a:gsLst>
-              <a:gs pos="0">
-                <a:srgbClr val="E8B23A">
-                  <a:alpha val="10000"/>
-                </a:srgbClr>
-              </a:gs>
-              <a:gs pos="100000">
-                <a:srgbClr val="E8B23A">
-                  <a:alpha val="0"/>
-                </a:srgbClr>
-              </a:gs>
-            </a:gsLst>
-            <a:path path="circle">
-              <a:fillToRect l="50000" t="50000" r="50000" b="50000"/>
-            </a:path>
-          </a:gradFill>
-          <a:ln>
-            <a:noFill/>
-          </a:ln>
-          <a:effectLst/>
-        </p:spPr>
-        <p:style>
-          <a:lnRef idx="1">
-            <a:schemeClr val="accent1"/>
-          </a:lnRef>
-          <a:fillRef idx="3">
-            <a:schemeClr val="accent1"/>
-          </a:fillRef>
-          <a:effectRef idx="2">
-            <a:schemeClr val="accent1"/>
-          </a:effectRef>
-          <a:fontRef idx="minor">
-            <a:schemeClr val="lt1"/>
-          </a:fontRef>
-        </p:style>
-        <p:txBody>
-          <a:bodyPr rtlCol="0" anchor="ctr"/>
-          <a:lstStyle/>
-          <a:p>
-            <a:pPr algn="ctr"/>
-          </a:p>
-        </p:txBody>
-      </p:sp>
-      <p:sp>
-        <p:nvSpPr>
-          <p:cNvPr id="7" name="Oval 6"/>
-          <p:cNvSpPr/>
-          <p:nvPr/>
-        </p:nvSpPr>
-        <p:spPr>
-          <a:xfrm>
-            <a:off x="1645919" y="3749039"/>
-            <a:ext cx="5852160" cy="1371600"/>
-          </a:xfrm>
-          <a:prstGeom prst="ellipse">
-            <a:avLst/>
-          </a:prstGeom>
-          <a:gradFill>
-            <a:gsLst>
-              <a:gs pos="0">
-                <a:srgbClr val="E8B23A">
-                  <a:alpha val="20000"/>
-                </a:srgbClr>
-              </a:gs>
-              <a:gs pos="100000">
-                <a:srgbClr val="E8B23A">
-                  <a:alpha val="0"/>
-                </a:srgbClr>
-              </a:gs>
-            </a:gsLst>
-            <a:path path="circle">
-              <a:fillToRect l="50000" t="50000" r="50000" b="50000"/>
-            </a:path>
-          </a:gradFill>
-          <a:ln>
-            <a:noFill/>
-          </a:ln>
-          <a:effectLst/>
-        </p:spPr>
-        <p:style>
-          <a:lnRef idx="1">
-            <a:schemeClr val="accent1"/>
-          </a:lnRef>
-          <a:fillRef idx="3">
-            <a:schemeClr val="accent1"/>
-          </a:fillRef>
-          <a:effectRef idx="2">
-            <a:schemeClr val="accent1"/>
-          </a:effectRef>
-          <a:fontRef idx="minor">
-            <a:schemeClr val="lt1"/>
-          </a:fontRef>
-        </p:style>
-        <p:txBody>
-          <a:bodyPr rtlCol="0" anchor="ctr"/>
-          <a:lstStyle/>
-          <a:p>
-            <a:pPr algn="ctr"/>
-          </a:p>
-        </p:txBody>
-      </p:sp>
-      <p:sp>
-        <p:nvSpPr>
-          <p:cNvPr id="8" name="TextBox 7"/>
+          <p:cNvPr id="5" name="TextBox 4"/>
           <p:cNvSpPr txBox="1"/>
           <p:nvPr/>
         </p:nvSpPr>
         <p:spPr>
           <a:xfrm>
-            <a:off x="640080" y="960120"/>
-            <a:ext cx="7863840" cy="274320"/>
+            <a:off x="640080" y="1371600"/>
+            <a:ext cx="4572000" cy="274320"/>
           </a:xfrm>
           <a:prstGeom prst="rect">
             <a:avLst/>
@@ -14442,7 +13836,7 @@
           </a:bodyPr>
           <a:lstStyle/>
           <a:p>
-            <a:pPr algn="ctr">
+            <a:pPr algn="l">
               <a:lnSpc>
                 <a:spcPct val="100000"/>
               </a:lnSpc>
@@ -14467,14 +13861,14 @@
       </p:sp>
       <p:sp>
         <p:nvSpPr>
-          <p:cNvPr id="9" name="TextBox 8"/>
+          <p:cNvPr id="6" name="TextBox 5"/>
           <p:cNvSpPr txBox="1"/>
           <p:nvPr/>
         </p:nvSpPr>
         <p:spPr>
           <a:xfrm>
-            <a:off x="640080" y="1600200"/>
-            <a:ext cx="7863840" cy="1371600"/>
+            <a:off x="640080" y="1847088"/>
+            <a:ext cx="4572000" cy="1234440"/>
           </a:xfrm>
           <a:prstGeom prst="rect">
             <a:avLst/>
@@ -14488,7 +13882,7 @@
           </a:bodyPr>
           <a:lstStyle/>
           <a:p>
-            <a:pPr algn="ctr">
+            <a:pPr algn="l">
               <a:lnSpc>
                 <a:spcPct val="102000"/>
               </a:lnSpc>
@@ -14510,7 +13904,7 @@
             </a:r>
           </a:p>
           <a:p>
-            <a:pPr algn="ctr">
+            <a:pPr algn="l">
               <a:lnSpc>
                 <a:spcPct val="102000"/>
               </a:lnSpc>
@@ -14544,14 +13938,14 @@
       </p:sp>
       <p:sp>
         <p:nvSpPr>
-          <p:cNvPr id="10" name="TextBox 9"/>
+          <p:cNvPr id="7" name="TextBox 6"/>
           <p:cNvSpPr txBox="1"/>
           <p:nvPr/>
         </p:nvSpPr>
         <p:spPr>
           <a:xfrm>
-            <a:off x="1554480" y="3977639"/>
-            <a:ext cx="6035040" cy="822960"/>
+            <a:off x="640080" y="3675887"/>
+            <a:ext cx="4572000" cy="1280160"/>
           </a:xfrm>
           <a:prstGeom prst="rect">
             <a:avLst/>
@@ -14565,7 +13959,7 @@
           </a:bodyPr>
           <a:lstStyle/>
           <a:p>
-            <a:pPr algn="ctr">
+            <a:pPr algn="l">
               <a:lnSpc>
                 <a:spcPct val="130000"/>
               </a:lnSpc>

</xml_diff>